<commit_message>
docs: harden hackathon deck claims and delivery
</commit_message>
<xml_diff>
--- a/docs/Tracebound-Open-Agent-Hackathon-Deck.pptx
+++ b/docs/Tracebound-Open-Agent-Hackathon-Deck.pptx
@@ -1775,7 +1775,7 @@
         <p:spPr>
           <a:xfrm>
             <a:off x="393192" y="4498848"/>
-            <a:ext cx="7498080" cy="804672"/>
+            <a:ext cx="7498080" cy="960120"/>
           </a:xfrm>
           <a:prstGeom prst="rect">
             <a:avLst/>
@@ -1920,8 +1920,8 @@
         </p:nvSpPr>
         <p:spPr>
           <a:xfrm>
-            <a:off x="9061704" y="2450592"/>
-            <a:ext cx="2331720" cy="960120"/>
+            <a:off x="9061704" y="2395728"/>
+            <a:ext cx="2331720" cy="1463040"/>
           </a:xfrm>
           <a:prstGeom prst="rect">
             <a:avLst/>
@@ -1978,7 +1978,7 @@
         </p:nvSpPr>
         <p:spPr>
           <a:xfrm>
-            <a:off x="9061704" y="3657600"/>
+            <a:off x="9061704" y="3913632"/>
             <a:ext cx="2304288" cy="0"/>
           </a:xfrm>
           <a:prstGeom prst="line">
@@ -2001,8 +2001,8 @@
         </p:nvSpPr>
         <p:spPr>
           <a:xfrm>
-            <a:off x="9061704" y="3941064"/>
-            <a:ext cx="1051560" cy="320040"/>
+            <a:off x="9061704" y="4087368"/>
+            <a:ext cx="1051560" cy="502920"/>
           </a:xfrm>
           <a:prstGeom prst="rect">
             <a:avLst/>
@@ -2042,8 +2042,8 @@
         </p:nvSpPr>
         <p:spPr>
           <a:xfrm>
-            <a:off x="10232136" y="3941064"/>
-            <a:ext cx="1115568" cy="320040"/>
+            <a:off x="10232136" y="4087368"/>
+            <a:ext cx="1115568" cy="502920"/>
           </a:xfrm>
           <a:prstGeom prst="rect">
             <a:avLst/>
@@ -2083,7 +2083,7 @@
         </p:nvSpPr>
         <p:spPr>
           <a:xfrm>
-            <a:off x="9061704" y="4608576"/>
+            <a:off x="9061704" y="4754880"/>
             <a:ext cx="2286000" cy="320040"/>
           </a:xfrm>
           <a:prstGeom prst="rect">
@@ -2914,17 +2914,17 @@
         </p:nvSpPr>
         <p:spPr>
           <a:xfrm>
-            <a:off x="3813048" y="2834640"/>
-            <a:ext cx="1033272" cy="274320"/>
-          </a:xfrm>
-          <a:prstGeom prst="rect">
-            <a:avLst/>
-          </a:prstGeom>
-          <a:noFill/>
-          <a:ln/>
-        </p:spPr>
-        <p:txBody>
-          <a:bodyPr wrap="square" lIns="0" tIns="0" rIns="0" bIns="0" rtlCol="0" anchor="t">
+            <a:off x="3813048" y="2779776"/>
+            <a:ext cx="1033272" cy="411480"/>
+          </a:xfrm>
+          <a:prstGeom prst="rect">
+            <a:avLst/>
+          </a:prstGeom>
+          <a:noFill/>
+          <a:ln/>
+        </p:spPr>
+        <p:txBody>
+          <a:bodyPr wrap="square" lIns="0" tIns="0" rIns="0" bIns="0" rtlCol="0" anchor="ctr">
             <a:normAutofit/>
           </a:bodyPr>
           <a:lstStyle/>
@@ -3557,8 +3557,8 @@
         </p:nvSpPr>
         <p:spPr>
           <a:xfrm>
-            <a:off x="393192" y="4133088"/>
-            <a:ext cx="2011680" cy="274320"/>
+            <a:off x="393192" y="4096512"/>
+            <a:ext cx="2011680" cy="512064"/>
           </a:xfrm>
           <a:prstGeom prst="rect">
             <a:avLst/>
@@ -3598,8 +3598,8 @@
         </p:nvSpPr>
         <p:spPr>
           <a:xfrm>
-            <a:off x="2322576" y="4133088"/>
-            <a:ext cx="2057400" cy="274320"/>
+            <a:off x="2322576" y="4096512"/>
+            <a:ext cx="2057400" cy="512064"/>
           </a:xfrm>
           <a:prstGeom prst="rect">
             <a:avLst/>
@@ -4072,7 +4072,7 @@
         <p:spPr>
           <a:xfrm>
             <a:off x="393192" y="1335024"/>
-            <a:ext cx="7772400" cy="384048"/>
+            <a:ext cx="7772400" cy="530352"/>
           </a:xfrm>
           <a:prstGeom prst="rect">
             <a:avLst/>
@@ -6027,8 +6027,8 @@
         </p:nvSpPr>
         <p:spPr>
           <a:xfrm>
-            <a:off x="6848856" y="5212080"/>
-            <a:ext cx="4315968" cy="502920"/>
+            <a:off x="6848856" y="5074920"/>
+            <a:ext cx="4315968" cy="749808"/>
           </a:xfrm>
           <a:prstGeom prst="rect">
             <a:avLst/>
@@ -7229,8 +7229,8 @@
         </p:nvSpPr>
         <p:spPr>
           <a:xfrm>
-            <a:off x="9125712" y="5001768"/>
-            <a:ext cx="2286000" cy="420624"/>
+            <a:off x="9125712" y="4965192"/>
+            <a:ext cx="2286000" cy="557784"/>
           </a:xfrm>
           <a:prstGeom prst="rect">
             <a:avLst/>
@@ -9320,7 +9320,7 @@
         <p:spPr>
           <a:xfrm>
             <a:off x="393192" y="2359152"/>
-            <a:ext cx="7132320" cy="475488"/>
+            <a:ext cx="7132320" cy="640080"/>
           </a:xfrm>
           <a:prstGeom prst="rect">
             <a:avLst/>
@@ -9425,7 +9425,7 @@
         <p:spPr>
           <a:xfrm>
             <a:off x="393192" y="4242816"/>
-            <a:ext cx="3127248" cy="841248"/>
+            <a:ext cx="3127248" cy="960120"/>
           </a:xfrm>
           <a:prstGeom prst="rect">
             <a:avLst/>
@@ -9530,7 +9530,7 @@
         <p:spPr>
           <a:xfrm>
             <a:off x="4242816" y="4242816"/>
-            <a:ext cx="3127248" cy="841248"/>
+            <a:ext cx="3127248" cy="960120"/>
           </a:xfrm>
           <a:prstGeom prst="rect">
             <a:avLst/>
@@ -9635,7 +9635,7 @@
         <p:spPr>
           <a:xfrm>
             <a:off x="8092440" y="4242816"/>
-            <a:ext cx="3127248" cy="841248"/>
+            <a:ext cx="3127248" cy="960120"/>
           </a:xfrm>
           <a:prstGeom prst="rect">
             <a:avLst/>

</xml_diff>